<commit_message>
add base paper figures to seminar deck
</commit_message>
<xml_diff>
--- a/presentation/mt_bench_labmeeting_study_seminar_v2.pptx
+++ b/presentation/mt_bench_labmeeting_study_seminar_v2.pptx
@@ -15141,8 +15141,170 @@
         </p:nvSpPr>
         <p:spPr>
           <a:xfrm>
-            <a:off x="594360" y="1298448"/>
-            <a:ext cx="5623560" cy="4526280"/>
+            <a:off x="640080" y="960120"/>
+            <a:ext cx="8046720" cy="237744"/>
+          </a:xfrm>
+          <a:prstGeom prst="rect">
+            <a:avLst/>
+          </a:prstGeom>
+          <a:noFill/>
+          <a:ln>
+            <a:noFill/>
+          </a:ln>
+        </p:spPr>
+        <p:txBody>
+          <a:bodyPr wrap="square" lIns="73152" rIns="73152" tIns="73152" bIns="73152" anchor="t">
+            <a:spAutoFit/>
+          </a:bodyPr>
+          <a:lstStyle/>
+          <a:p>
+            <a:pPr algn="l"/>
+            <a:r>
+              <a:rPr sz="1300" b="1">
+                <a:solidFill>
+                  <a:srgbClr val="B45C45"/>
+                </a:solidFill>
+                <a:latin typeface="Apple SD Gothic Neo"/>
+              </a:rPr>
+              <a:t>Base paper question: “Can a strong LLM approximate human preference at scale?”</a:t>
+            </a:r>
+          </a:p>
+        </p:txBody>
+      </p:sp>
+      <p:pic>
+        <p:nvPicPr>
+          <p:cNvPr id="7" name="Picture 6" descr="paper_chatbot_arena_ui.png"/>
+          <p:cNvPicPr>
+            <a:picLocks noChangeAspect="1"/>
+          </p:cNvPicPr>
+          <p:nvPr/>
+        </p:nvPicPr>
+        <p:blipFill>
+          <a:blip r:embed="rId2"/>
+          <a:stretch>
+            <a:fillRect/>
+          </a:stretch>
+        </p:blipFill>
+        <p:spPr>
+          <a:xfrm>
+            <a:off x="566928" y="1298448"/>
+            <a:ext cx="3611880" cy="2828538"/>
+          </a:xfrm>
+          <a:prstGeom prst="rect">
+            <a:avLst/>
+          </a:prstGeom>
+        </p:spPr>
+      </p:pic>
+      <p:pic>
+        <p:nvPicPr>
+          <p:cNvPr id="8" name="Picture 7" descr="paper_mtbench_winrate_fig3.png"/>
+          <p:cNvPicPr>
+            <a:picLocks noChangeAspect="1"/>
+          </p:cNvPicPr>
+          <p:nvPr/>
+        </p:nvPicPr>
+        <p:blipFill>
+          <a:blip r:embed="rId3"/>
+          <a:stretch>
+            <a:fillRect/>
+          </a:stretch>
+        </p:blipFill>
+        <p:spPr>
+          <a:xfrm>
+            <a:off x="4407408" y="1298448"/>
+            <a:ext cx="3611880" cy="1956435"/>
+          </a:xfrm>
+          <a:prstGeom prst="rect">
+            <a:avLst/>
+          </a:prstGeom>
+        </p:spPr>
+      </p:pic>
+      <p:sp>
+        <p:nvSpPr>
+          <p:cNvPr id="9" name="TextBox 8"/>
+          <p:cNvSpPr txBox="1"/>
+          <p:nvPr/>
+        </p:nvSpPr>
+        <p:spPr>
+          <a:xfrm>
+            <a:off x="640080" y="4626864"/>
+            <a:ext cx="3474720" cy="219456"/>
+          </a:xfrm>
+          <a:prstGeom prst="rect">
+            <a:avLst/>
+          </a:prstGeom>
+          <a:noFill/>
+          <a:ln>
+            <a:noFill/>
+          </a:ln>
+        </p:spPr>
+        <p:txBody>
+          <a:bodyPr wrap="square" lIns="73152" rIns="73152" tIns="73152" bIns="73152" anchor="t">
+            <a:spAutoFit/>
+          </a:bodyPr>
+          <a:lstStyle/>
+          <a:p>
+            <a:pPr algn="ctr"/>
+            <a:r>
+              <a:rPr sz="1100" b="0">
+                <a:solidFill>
+                  <a:srgbClr val="6D7780"/>
+                </a:solidFill>
+                <a:latin typeface="Apple SD Gothic Neo"/>
+              </a:rPr>
+              <a:t>Original paper: Chatbot Arena UI screenshot (Figure 19)</a:t>
+            </a:r>
+          </a:p>
+        </p:txBody>
+      </p:sp>
+      <p:sp>
+        <p:nvSpPr>
+          <p:cNvPr id="10" name="TextBox 9"/>
+          <p:cNvSpPr txBox="1"/>
+          <p:nvPr/>
+        </p:nvSpPr>
+        <p:spPr>
+          <a:xfrm>
+            <a:off x="4480560" y="4626864"/>
+            <a:ext cx="3474720" cy="219456"/>
+          </a:xfrm>
+          <a:prstGeom prst="rect">
+            <a:avLst/>
+          </a:prstGeom>
+          <a:noFill/>
+          <a:ln>
+            <a:noFill/>
+          </a:ln>
+        </p:spPr>
+        <p:txBody>
+          <a:bodyPr wrap="square" lIns="73152" rIns="73152" tIns="73152" bIns="73152" anchor="t">
+            <a:spAutoFit/>
+          </a:bodyPr>
+          <a:lstStyle/>
+          <a:p>
+            <a:pPr algn="ctr"/>
+            <a:r>
+              <a:rPr sz="1100" b="0">
+                <a:solidFill>
+                  <a:srgbClr val="6D7780"/>
+                </a:solidFill>
+                <a:latin typeface="Apple SD Gothic Neo"/>
+              </a:rPr>
+              <a:t>Original paper: MT-Bench average win-rate curves (Figure 3)</a:t>
+            </a:r>
+          </a:p>
+        </p:txBody>
+      </p:sp>
+      <p:sp>
+        <p:nvSpPr>
+          <p:cNvPr id="11" name="TextBox 10"/>
+          <p:cNvSpPr txBox="1"/>
+          <p:nvPr/>
+        </p:nvSpPr>
+        <p:spPr>
+          <a:xfrm>
+            <a:off x="8183879" y="1298448"/>
+            <a:ext cx="3246120" cy="4709160"/>
           </a:xfrm>
           <a:prstGeom prst="rect">
             <a:avLst/>
@@ -15157,7 +15319,7 @@
           </a:ln>
         </p:spPr>
         <p:txBody>
-          <a:bodyPr wrap="square" lIns="73152" rIns="73152" tIns="73152" bIns="73152" anchor="t">
+          <a:bodyPr wrap="square" lIns="128016" rIns="128016" tIns="128016" bIns="128016" anchor="t">
             <a:spAutoFit/>
           </a:bodyPr>
           <a:lstStyle/>
@@ -15172,7 +15334,7 @@
               <a:spcAft>
                 <a:spcPts val="900"/>
               </a:spcAft>
-              <a:defRPr sz="1800">
+              <a:defRPr sz="1700">
                 <a:solidFill>
                   <a:srgbClr val="36454F"/>
                 </a:solidFill>
@@ -15194,7 +15356,7 @@
               <a:spcAft>
                 <a:spcPts val="900"/>
               </a:spcAft>
-              <a:defRPr sz="1800">
+              <a:defRPr sz="1700">
                 <a:solidFill>
                   <a:srgbClr val="36454F"/>
                 </a:solidFill>
@@ -15216,7 +15378,7 @@
               <a:spcAft>
                 <a:spcPts val="900"/>
               </a:spcAft>
-              <a:defRPr sz="1800">
+              <a:defRPr sz="1700">
                 <a:solidFill>
                   <a:srgbClr val="36454F"/>
                 </a:solidFill>
@@ -15231,104 +15393,20 @@
       </p:sp>
       <p:sp>
         <p:nvSpPr>
-          <p:cNvPr id="7" name="TextBox 6"/>
-          <p:cNvSpPr txBox="1"/>
-          <p:nvPr/>
-        </p:nvSpPr>
-        <p:spPr>
-          <a:xfrm>
-            <a:off x="6446520" y="1298448"/>
-            <a:ext cx="4709160" cy="658368"/>
+          <p:cNvPr id="12" name="Rectangle 11"/>
+          <p:cNvSpPr/>
+          <p:nvPr/>
+        </p:nvSpPr>
+        <p:spPr>
+          <a:xfrm>
+            <a:off x="384048" y="6510528"/>
+            <a:ext cx="11384280" cy="36576"/>
           </a:xfrm>
           <a:prstGeom prst="rect">
             <a:avLst/>
           </a:prstGeom>
           <a:solidFill>
-            <a:srgbClr val="13283A"/>
-          </a:solidFill>
-          <a:ln>
-            <a:solidFill>
-              <a:srgbClr val="13283A"/>
-            </a:solidFill>
-          </a:ln>
-        </p:spPr>
-        <p:txBody>
-          <a:bodyPr wrap="square" lIns="73152" rIns="73152" tIns="73152" bIns="73152" anchor="ctr">
-            <a:spAutoFit/>
-          </a:bodyPr>
-          <a:lstStyle/>
-          <a:p>
-            <a:pPr algn="l"/>
-            <a:r>
-              <a:rPr sz="1900" b="1">
-                <a:solidFill>
-                  <a:srgbClr val="FFFFFF"/>
-                </a:solidFill>
-                <a:latin typeface="Apple SD Gothic Neo"/>
-              </a:rPr>
-              <a:t>Base paper question: “Can a strong LLM approximate human preference at scale?”</a:t>
-            </a:r>
-          </a:p>
-        </p:txBody>
-      </p:sp>
-      <p:sp>
-        <p:nvSpPr>
-          <p:cNvPr id="8" name="TextBox 7"/>
-          <p:cNvSpPr txBox="1"/>
-          <p:nvPr/>
-        </p:nvSpPr>
-        <p:spPr>
-          <a:xfrm>
-            <a:off x="6510528" y="2377440"/>
-            <a:ext cx="1645920" cy="868680"/>
-          </a:xfrm>
-          <a:prstGeom prst="rect">
-            <a:avLst/>
-          </a:prstGeom>
-          <a:solidFill>
-            <a:srgbClr val="FFFFFF"/>
-          </a:solidFill>
-          <a:ln>
-            <a:solidFill>
-              <a:srgbClr val="E9E5DB"/>
-            </a:solidFill>
-          </a:ln>
-        </p:spPr>
-        <p:txBody>
-          <a:bodyPr wrap="square" lIns="109728" rIns="109728" tIns="109728" bIns="109728" anchor="t">
-            <a:spAutoFit/>
-          </a:bodyPr>
-          <a:lstStyle/>
-          <a:p>
-            <a:pPr algn="l"/>
-            <a:r>
-              <a:rPr sz="1800" b="0">
-                <a:solidFill>
-                  <a:srgbClr val="36454F"/>
-                </a:solidFill>
-                <a:latin typeface="Apple SD Gothic Neo"/>
-              </a:rPr>
-              <a:t/>
-            </a:r>
-          </a:p>
-        </p:txBody>
-      </p:sp>
-      <p:sp>
-        <p:nvSpPr>
-          <p:cNvPr id="9" name="Rounded Rectangle 8"/>
-          <p:cNvSpPr/>
-          <p:nvPr/>
-        </p:nvSpPr>
-        <p:spPr>
-          <a:xfrm>
-            <a:off x="6620256" y="2487168"/>
-            <a:ext cx="438912" cy="201168"/>
-          </a:xfrm>
-          <a:prstGeom prst="roundRect">
-            <a:avLst/>
-          </a:prstGeom>
-          <a:solidFill>
-            <a:srgbClr val="B45C45"/>
+            <a:srgbClr val="E9E5DB"/>
           </a:solidFill>
           <a:ln>
             <a:noFill/>
@@ -15358,609 +15436,7 @@
       </p:sp>
       <p:sp>
         <p:nvSpPr>
-          <p:cNvPr id="10" name="TextBox 9"/>
-          <p:cNvSpPr txBox="1"/>
-          <p:nvPr/>
-        </p:nvSpPr>
-        <p:spPr>
-          <a:xfrm>
-            <a:off x="6620256" y="2542032"/>
-            <a:ext cx="1417320" cy="164592"/>
-          </a:xfrm>
-          <a:prstGeom prst="rect">
-            <a:avLst/>
-          </a:prstGeom>
-          <a:noFill/>
-          <a:ln>
-            <a:noFill/>
-          </a:ln>
-        </p:spPr>
-        <p:txBody>
-          <a:bodyPr wrap="square" lIns="18288" rIns="18288" tIns="18288" bIns="18288" anchor="ctr">
-            <a:spAutoFit/>
-          </a:bodyPr>
-          <a:lstStyle/>
-          <a:p>
-            <a:pPr algn="l"/>
-            <a:r>
-              <a:rPr sz="1000" b="1">
-                <a:solidFill>
-                  <a:srgbClr val="FFFFFF"/>
-                </a:solidFill>
-                <a:latin typeface="Apple SD Gothic Neo"/>
-              </a:rPr>
-              <a:t>MT-Bench</a:t>
-            </a:r>
-          </a:p>
-        </p:txBody>
-      </p:sp>
-      <p:sp>
-        <p:nvSpPr>
-          <p:cNvPr id="11" name="TextBox 10"/>
-          <p:cNvSpPr txBox="1"/>
-          <p:nvPr/>
-        </p:nvSpPr>
-        <p:spPr>
-          <a:xfrm>
-            <a:off x="6620256" y="2761488"/>
-            <a:ext cx="1426464" cy="320040"/>
-          </a:xfrm>
-          <a:prstGeom prst="rect">
-            <a:avLst/>
-          </a:prstGeom>
-          <a:noFill/>
-          <a:ln>
-            <a:noFill/>
-          </a:ln>
-        </p:spPr>
-        <p:txBody>
-          <a:bodyPr wrap="square" lIns="18288" rIns="18288" tIns="18288" bIns="18288" anchor="t">
-            <a:spAutoFit/>
-          </a:bodyPr>
-          <a:lstStyle/>
-          <a:p>
-            <a:pPr algn="l"/>
-            <a:r>
-              <a:rPr sz="2100" b="1">
-                <a:solidFill>
-                  <a:srgbClr val="13283A"/>
-                </a:solidFill>
-                <a:latin typeface="Apple SD Gothic Neo"/>
-              </a:rPr>
-              <a:t>80문항</a:t>
-            </a:r>
-          </a:p>
-        </p:txBody>
-      </p:sp>
-      <p:sp>
-        <p:nvSpPr>
-          <p:cNvPr id="12" name="TextBox 11"/>
-          <p:cNvSpPr txBox="1"/>
-          <p:nvPr/>
-        </p:nvSpPr>
-        <p:spPr>
-          <a:xfrm>
-            <a:off x="8979408" y="2377440"/>
-            <a:ext cx="1645920" cy="868680"/>
-          </a:xfrm>
-          <a:prstGeom prst="rect">
-            <a:avLst/>
-          </a:prstGeom>
-          <a:solidFill>
-            <a:srgbClr val="FFFFFF"/>
-          </a:solidFill>
-          <a:ln>
-            <a:solidFill>
-              <a:srgbClr val="E9E5DB"/>
-            </a:solidFill>
-          </a:ln>
-        </p:spPr>
-        <p:txBody>
-          <a:bodyPr wrap="square" lIns="109728" rIns="109728" tIns="109728" bIns="109728" anchor="t">
-            <a:spAutoFit/>
-          </a:bodyPr>
-          <a:lstStyle/>
-          <a:p>
-            <a:pPr algn="l"/>
-            <a:r>
-              <a:rPr sz="1800" b="0">
-                <a:solidFill>
-                  <a:srgbClr val="36454F"/>
-                </a:solidFill>
-                <a:latin typeface="Apple SD Gothic Neo"/>
-              </a:rPr>
-              <a:t/>
-            </a:r>
-          </a:p>
-        </p:txBody>
-      </p:sp>
-      <p:sp>
-        <p:nvSpPr>
-          <p:cNvPr id="13" name="Rounded Rectangle 12"/>
-          <p:cNvSpPr/>
-          <p:nvPr/>
-        </p:nvSpPr>
-        <p:spPr>
-          <a:xfrm>
-            <a:off x="9089136" y="2487168"/>
-            <a:ext cx="438912" cy="201168"/>
-          </a:xfrm>
-          <a:prstGeom prst="roundRect">
-            <a:avLst/>
-          </a:prstGeom>
-          <a:solidFill>
-            <a:srgbClr val="607A60"/>
-          </a:solidFill>
-          <a:ln>
-            <a:noFill/>
-          </a:ln>
-        </p:spPr>
-        <p:style>
-          <a:lnRef idx="1">
-            <a:schemeClr val="accent1"/>
-          </a:lnRef>
-          <a:fillRef idx="3">
-            <a:schemeClr val="accent1"/>
-          </a:fillRef>
-          <a:effectRef idx="2">
-            <a:schemeClr val="accent1"/>
-          </a:effectRef>
-          <a:fontRef idx="minor">
-            <a:schemeClr val="lt1"/>
-          </a:fontRef>
-        </p:style>
-        <p:txBody>
-          <a:bodyPr rtlCol="0" anchor="ctr"/>
-          <a:lstStyle/>
-          <a:p>
-            <a:pPr algn="ctr"/>
-          </a:p>
-        </p:txBody>
-      </p:sp>
-      <p:sp>
-        <p:nvSpPr>
-          <p:cNvPr id="14" name="TextBox 13"/>
-          <p:cNvSpPr txBox="1"/>
-          <p:nvPr/>
-        </p:nvSpPr>
-        <p:spPr>
-          <a:xfrm>
-            <a:off x="9089136" y="2542032"/>
-            <a:ext cx="1417320" cy="164592"/>
-          </a:xfrm>
-          <a:prstGeom prst="rect">
-            <a:avLst/>
-          </a:prstGeom>
-          <a:noFill/>
-          <a:ln>
-            <a:noFill/>
-          </a:ln>
-        </p:spPr>
-        <p:txBody>
-          <a:bodyPr wrap="square" lIns="18288" rIns="18288" tIns="18288" bIns="18288" anchor="ctr">
-            <a:spAutoFit/>
-          </a:bodyPr>
-          <a:lstStyle/>
-          <a:p>
-            <a:pPr algn="l"/>
-            <a:r>
-              <a:rPr sz="1000" b="1">
-                <a:solidFill>
-                  <a:srgbClr val="FFFFFF"/>
-                </a:solidFill>
-                <a:latin typeface="Apple SD Gothic Neo"/>
-              </a:rPr>
-              <a:t>Arena</a:t>
-            </a:r>
-          </a:p>
-        </p:txBody>
-      </p:sp>
-      <p:sp>
-        <p:nvSpPr>
-          <p:cNvPr id="15" name="TextBox 14"/>
-          <p:cNvSpPr txBox="1"/>
-          <p:nvPr/>
-        </p:nvSpPr>
-        <p:spPr>
-          <a:xfrm>
-            <a:off x="9089136" y="2761488"/>
-            <a:ext cx="1426464" cy="320040"/>
-          </a:xfrm>
-          <a:prstGeom prst="rect">
-            <a:avLst/>
-          </a:prstGeom>
-          <a:noFill/>
-          <a:ln>
-            <a:noFill/>
-          </a:ln>
-        </p:spPr>
-        <p:txBody>
-          <a:bodyPr wrap="square" lIns="18288" rIns="18288" tIns="18288" bIns="18288" anchor="t">
-            <a:spAutoFit/>
-          </a:bodyPr>
-          <a:lstStyle/>
-          <a:p>
-            <a:pPr algn="l"/>
-            <a:r>
-              <a:rPr sz="2100" b="1">
-                <a:solidFill>
-                  <a:srgbClr val="13283A"/>
-                </a:solidFill>
-                <a:latin typeface="Apple SD Gothic Neo"/>
-              </a:rPr>
-              <a:t>30K 대화</a:t>
-            </a:r>
-          </a:p>
-        </p:txBody>
-      </p:sp>
-      <p:sp>
-        <p:nvSpPr>
-          <p:cNvPr id="16" name="TextBox 15"/>
-          <p:cNvSpPr txBox="1"/>
-          <p:nvPr/>
-        </p:nvSpPr>
-        <p:spPr>
-          <a:xfrm>
-            <a:off x="6510528" y="3547872"/>
-            <a:ext cx="1645920" cy="868680"/>
-          </a:xfrm>
-          <a:prstGeom prst="rect">
-            <a:avLst/>
-          </a:prstGeom>
-          <a:solidFill>
-            <a:srgbClr val="FFFFFF"/>
-          </a:solidFill>
-          <a:ln>
-            <a:solidFill>
-              <a:srgbClr val="E9E5DB"/>
-            </a:solidFill>
-          </a:ln>
-        </p:spPr>
-        <p:txBody>
-          <a:bodyPr wrap="square" lIns="109728" rIns="109728" tIns="109728" bIns="109728" anchor="t">
-            <a:spAutoFit/>
-          </a:bodyPr>
-          <a:lstStyle/>
-          <a:p>
-            <a:pPr algn="l"/>
-            <a:r>
-              <a:rPr sz="1800" b="0">
-                <a:solidFill>
-                  <a:srgbClr val="36454F"/>
-                </a:solidFill>
-                <a:latin typeface="Apple SD Gothic Neo"/>
-              </a:rPr>
-              <a:t/>
-            </a:r>
-          </a:p>
-        </p:txBody>
-      </p:sp>
-      <p:sp>
-        <p:nvSpPr>
-          <p:cNvPr id="17" name="Rounded Rectangle 16"/>
-          <p:cNvSpPr/>
-          <p:nvPr/>
-        </p:nvSpPr>
-        <p:spPr>
-          <a:xfrm>
-            <a:off x="6620256" y="3657600"/>
-            <a:ext cx="438912" cy="201168"/>
-          </a:xfrm>
-          <a:prstGeom prst="roundRect">
-            <a:avLst/>
-          </a:prstGeom>
-          <a:solidFill>
-            <a:srgbClr val="C0944A"/>
-          </a:solidFill>
-          <a:ln>
-            <a:noFill/>
-          </a:ln>
-        </p:spPr>
-        <p:style>
-          <a:lnRef idx="1">
-            <a:schemeClr val="accent1"/>
-          </a:lnRef>
-          <a:fillRef idx="3">
-            <a:schemeClr val="accent1"/>
-          </a:fillRef>
-          <a:effectRef idx="2">
-            <a:schemeClr val="accent1"/>
-          </a:effectRef>
-          <a:fontRef idx="minor">
-            <a:schemeClr val="lt1"/>
-          </a:fontRef>
-        </p:style>
-        <p:txBody>
-          <a:bodyPr rtlCol="0" anchor="ctr"/>
-          <a:lstStyle/>
-          <a:p>
-            <a:pPr algn="ctr"/>
-          </a:p>
-        </p:txBody>
-      </p:sp>
-      <p:sp>
-        <p:nvSpPr>
-          <p:cNvPr id="18" name="TextBox 17"/>
-          <p:cNvSpPr txBox="1"/>
-          <p:nvPr/>
-        </p:nvSpPr>
-        <p:spPr>
-          <a:xfrm>
-            <a:off x="6620256" y="3712464"/>
-            <a:ext cx="1417320" cy="164592"/>
-          </a:xfrm>
-          <a:prstGeom prst="rect">
-            <a:avLst/>
-          </a:prstGeom>
-          <a:noFill/>
-          <a:ln>
-            <a:noFill/>
-          </a:ln>
-        </p:spPr>
-        <p:txBody>
-          <a:bodyPr wrap="square" lIns="18288" rIns="18288" tIns="18288" bIns="18288" anchor="ctr">
-            <a:spAutoFit/>
-          </a:bodyPr>
-          <a:lstStyle/>
-          <a:p>
-            <a:pPr algn="l"/>
-            <a:r>
-              <a:rPr sz="1000" b="1">
-                <a:solidFill>
-                  <a:srgbClr val="FFFFFF"/>
-                </a:solidFill>
-                <a:latin typeface="Apple SD Gothic Neo"/>
-              </a:rPr>
-              <a:t>expert</a:t>
-            </a:r>
-          </a:p>
-        </p:txBody>
-      </p:sp>
-      <p:sp>
-        <p:nvSpPr>
-          <p:cNvPr id="19" name="TextBox 18"/>
-          <p:cNvSpPr txBox="1"/>
-          <p:nvPr/>
-        </p:nvSpPr>
-        <p:spPr>
-          <a:xfrm>
-            <a:off x="6620256" y="3931920"/>
-            <a:ext cx="1426464" cy="320040"/>
-          </a:xfrm>
-          <a:prstGeom prst="rect">
-            <a:avLst/>
-          </a:prstGeom>
-          <a:noFill/>
-          <a:ln>
-            <a:noFill/>
-          </a:ln>
-        </p:spPr>
-        <p:txBody>
-          <a:bodyPr wrap="square" lIns="18288" rIns="18288" tIns="18288" bIns="18288" anchor="t">
-            <a:spAutoFit/>
-          </a:bodyPr>
-          <a:lstStyle/>
-          <a:p>
-            <a:pPr algn="l"/>
-            <a:r>
-              <a:rPr sz="2100" b="1">
-                <a:solidFill>
-                  <a:srgbClr val="13283A"/>
-                </a:solidFill>
-                <a:latin typeface="Apple SD Gothic Neo"/>
-              </a:rPr>
-              <a:t>약 3K 표</a:t>
-            </a:r>
-          </a:p>
-        </p:txBody>
-      </p:sp>
-      <p:sp>
-        <p:nvSpPr>
-          <p:cNvPr id="20" name="TextBox 19"/>
-          <p:cNvSpPr txBox="1"/>
-          <p:nvPr/>
-        </p:nvSpPr>
-        <p:spPr>
-          <a:xfrm>
-            <a:off x="8979408" y="3547872"/>
-            <a:ext cx="1645920" cy="868680"/>
-          </a:xfrm>
-          <a:prstGeom prst="rect">
-            <a:avLst/>
-          </a:prstGeom>
-          <a:solidFill>
-            <a:srgbClr val="FFFFFF"/>
-          </a:solidFill>
-          <a:ln>
-            <a:solidFill>
-              <a:srgbClr val="E9E5DB"/>
-            </a:solidFill>
-          </a:ln>
-        </p:spPr>
-        <p:txBody>
-          <a:bodyPr wrap="square" lIns="109728" rIns="109728" tIns="109728" bIns="109728" anchor="t">
-            <a:spAutoFit/>
-          </a:bodyPr>
-          <a:lstStyle/>
-          <a:p>
-            <a:pPr algn="l"/>
-            <a:r>
-              <a:rPr sz="1800" b="0">
-                <a:solidFill>
-                  <a:srgbClr val="36454F"/>
-                </a:solidFill>
-                <a:latin typeface="Apple SD Gothic Neo"/>
-              </a:rPr>
-              <a:t/>
-            </a:r>
-          </a:p>
-        </p:txBody>
-      </p:sp>
-      <p:sp>
-        <p:nvSpPr>
-          <p:cNvPr id="21" name="Rounded Rectangle 20"/>
-          <p:cNvSpPr/>
-          <p:nvPr/>
-        </p:nvSpPr>
-        <p:spPr>
-          <a:xfrm>
-            <a:off x="9089136" y="3657600"/>
-            <a:ext cx="438912" cy="201168"/>
-          </a:xfrm>
-          <a:prstGeom prst="roundRect">
-            <a:avLst/>
-          </a:prstGeom>
-          <a:solidFill>
-            <a:srgbClr val="13283A"/>
-          </a:solidFill>
-          <a:ln>
-            <a:noFill/>
-          </a:ln>
-        </p:spPr>
-        <p:style>
-          <a:lnRef idx="1">
-            <a:schemeClr val="accent1"/>
-          </a:lnRef>
-          <a:fillRef idx="3">
-            <a:schemeClr val="accent1"/>
-          </a:fillRef>
-          <a:effectRef idx="2">
-            <a:schemeClr val="accent1"/>
-          </a:effectRef>
-          <a:fontRef idx="minor">
-            <a:schemeClr val="lt1"/>
-          </a:fontRef>
-        </p:style>
-        <p:txBody>
-          <a:bodyPr rtlCol="0" anchor="ctr"/>
-          <a:lstStyle/>
-          <a:p>
-            <a:pPr algn="ctr"/>
-          </a:p>
-        </p:txBody>
-      </p:sp>
-      <p:sp>
-        <p:nvSpPr>
-          <p:cNvPr id="22" name="TextBox 21"/>
-          <p:cNvSpPr txBox="1"/>
-          <p:nvPr/>
-        </p:nvSpPr>
-        <p:spPr>
-          <a:xfrm>
-            <a:off x="9089136" y="3712464"/>
-            <a:ext cx="1417320" cy="164592"/>
-          </a:xfrm>
-          <a:prstGeom prst="rect">
-            <a:avLst/>
-          </a:prstGeom>
-          <a:noFill/>
-          <a:ln>
-            <a:noFill/>
-          </a:ln>
-        </p:spPr>
-        <p:txBody>
-          <a:bodyPr wrap="square" lIns="18288" rIns="18288" tIns="18288" bIns="18288" anchor="ctr">
-            <a:spAutoFit/>
-          </a:bodyPr>
-          <a:lstStyle/>
-          <a:p>
-            <a:pPr algn="l"/>
-            <a:r>
-              <a:rPr sz="1000" b="1">
-                <a:solidFill>
-                  <a:srgbClr val="FFFFFF"/>
-                </a:solidFill>
-                <a:latin typeface="Apple SD Gothic Neo"/>
-              </a:rPr>
-              <a:t>질문</a:t>
-            </a:r>
-          </a:p>
-        </p:txBody>
-      </p:sp>
-      <p:sp>
-        <p:nvSpPr>
-          <p:cNvPr id="23" name="TextBox 22"/>
-          <p:cNvSpPr txBox="1"/>
-          <p:nvPr/>
-        </p:nvSpPr>
-        <p:spPr>
-          <a:xfrm>
-            <a:off x="9089136" y="3931920"/>
-            <a:ext cx="1426464" cy="320040"/>
-          </a:xfrm>
-          <a:prstGeom prst="rect">
-            <a:avLst/>
-          </a:prstGeom>
-          <a:noFill/>
-          <a:ln>
-            <a:noFill/>
-          </a:ln>
-        </p:spPr>
-        <p:txBody>
-          <a:bodyPr wrap="square" lIns="18288" rIns="18288" tIns="18288" bIns="18288" anchor="t">
-            <a:spAutoFit/>
-          </a:bodyPr>
-          <a:lstStyle/>
-          <a:p>
-            <a:pPr algn="l"/>
-            <a:r>
-              <a:rPr sz="2100" b="1">
-                <a:solidFill>
-                  <a:srgbClr val="13283A"/>
-                </a:solidFill>
-                <a:latin typeface="Apple SD Gothic Neo"/>
-              </a:rPr>
-              <a:t>human proxy?</a:t>
-            </a:r>
-          </a:p>
-        </p:txBody>
-      </p:sp>
-      <p:sp>
-        <p:nvSpPr>
-          <p:cNvPr id="24" name="Rectangle 23"/>
-          <p:cNvSpPr/>
-          <p:nvPr/>
-        </p:nvSpPr>
-        <p:spPr>
-          <a:xfrm>
-            <a:off x="384048" y="6510528"/>
-            <a:ext cx="11384280" cy="36576"/>
-          </a:xfrm>
-          <a:prstGeom prst="rect">
-            <a:avLst/>
-          </a:prstGeom>
-          <a:solidFill>
-            <a:srgbClr val="E9E5DB"/>
-          </a:solidFill>
-          <a:ln>
-            <a:noFill/>
-          </a:ln>
-        </p:spPr>
-        <p:style>
-          <a:lnRef idx="1">
-            <a:schemeClr val="accent1"/>
-          </a:lnRef>
-          <a:fillRef idx="3">
-            <a:schemeClr val="accent1"/>
-          </a:fillRef>
-          <a:effectRef idx="2">
-            <a:schemeClr val="accent1"/>
-          </a:effectRef>
-          <a:fontRef idx="minor">
-            <a:schemeClr val="lt1"/>
-          </a:fontRef>
-        </p:style>
-        <p:txBody>
-          <a:bodyPr rtlCol="0" anchor="ctr"/>
-          <a:lstStyle/>
-          <a:p>
-            <a:pPr algn="ctr"/>
-          </a:p>
-        </p:txBody>
-      </p:sp>
-      <p:sp>
-        <p:nvSpPr>
-          <p:cNvPr id="25" name="TextBox 24"/>
+          <p:cNvPr id="13" name="TextBox 12"/>
           <p:cNvSpPr txBox="1"/>
           <p:nvPr/>
         </p:nvSpPr>
@@ -16187,8 +15663,170 @@
         </p:nvSpPr>
         <p:spPr>
           <a:xfrm>
-            <a:off x="594360" y="1298448"/>
-            <a:ext cx="5623560" cy="4526280"/>
+            <a:off x="640080" y="960120"/>
+            <a:ext cx="8046720" cy="237744"/>
+          </a:xfrm>
+          <a:prstGeom prst="rect">
+            <a:avLst/>
+          </a:prstGeom>
+          <a:noFill/>
+          <a:ln>
+            <a:noFill/>
+          </a:ln>
+        </p:spPr>
+        <p:txBody>
+          <a:bodyPr wrap="square" lIns="73152" rIns="73152" tIns="73152" bIns="73152" anchor="t">
+            <a:spAutoFit/>
+          </a:bodyPr>
+          <a:lstStyle/>
+          <a:p>
+            <a:pPr algn="l"/>
+            <a:r>
+              <a:rPr sz="1300" b="1">
+                <a:solidFill>
+                  <a:srgbClr val="B45C45"/>
+                </a:solidFill>
+                <a:latin typeface="Apple SD Gothic Neo"/>
+              </a:rPr>
+              <a:t>원 논문의 결론은 ‘GPT-4 judge가 완벽하다’가 아니라, ‘인간 선호를 실용적으로 근사할 수 있다’였습니다.</a:t>
+            </a:r>
+          </a:p>
+        </p:txBody>
+      </p:sp>
+      <p:pic>
+        <p:nvPicPr>
+          <p:cNvPr id="7" name="Picture 6" descr="paper_mtbench_agreement_table5.png"/>
+          <p:cNvPicPr>
+            <a:picLocks noChangeAspect="1"/>
+          </p:cNvPicPr>
+          <p:nvPr/>
+        </p:nvPicPr>
+        <p:blipFill>
+          <a:blip r:embed="rId2"/>
+          <a:stretch>
+            <a:fillRect/>
+          </a:stretch>
+        </p:blipFill>
+        <p:spPr>
+          <a:xfrm>
+            <a:off x="566928" y="1298448"/>
+            <a:ext cx="3611880" cy="1602622"/>
+          </a:xfrm>
+          <a:prstGeom prst="rect">
+            <a:avLst/>
+          </a:prstGeom>
+        </p:spPr>
+      </p:pic>
+      <p:pic>
+        <p:nvPicPr>
+          <p:cNvPr id="8" name="Picture 7" descr="paper_table8_scores.png"/>
+          <p:cNvPicPr>
+            <a:picLocks noChangeAspect="1"/>
+          </p:cNvPicPr>
+          <p:nvPr/>
+        </p:nvPicPr>
+        <p:blipFill>
+          <a:blip r:embed="rId3"/>
+          <a:stretch>
+            <a:fillRect/>
+          </a:stretch>
+        </p:blipFill>
+        <p:spPr>
+          <a:xfrm>
+            <a:off x="4407408" y="1298448"/>
+            <a:ext cx="3611880" cy="1435491"/>
+          </a:xfrm>
+          <a:prstGeom prst="rect">
+            <a:avLst/>
+          </a:prstGeom>
+        </p:spPr>
+      </p:pic>
+      <p:sp>
+        <p:nvSpPr>
+          <p:cNvPr id="9" name="TextBox 8"/>
+          <p:cNvSpPr txBox="1"/>
+          <p:nvPr/>
+        </p:nvSpPr>
+        <p:spPr>
+          <a:xfrm>
+            <a:off x="640080" y="4626864"/>
+            <a:ext cx="3474720" cy="219456"/>
+          </a:xfrm>
+          <a:prstGeom prst="rect">
+            <a:avLst/>
+          </a:prstGeom>
+          <a:noFill/>
+          <a:ln>
+            <a:noFill/>
+          </a:ln>
+        </p:spPr>
+        <p:txBody>
+          <a:bodyPr wrap="square" lIns="73152" rIns="73152" tIns="73152" bIns="73152" anchor="t">
+            <a:spAutoFit/>
+          </a:bodyPr>
+          <a:lstStyle/>
+          <a:p>
+            <a:pPr algn="ctr"/>
+            <a:r>
+              <a:rPr sz="1100" b="0">
+                <a:solidFill>
+                  <a:srgbClr val="6D7780"/>
+                </a:solidFill>
+                <a:latin typeface="Apple SD Gothic Neo"/>
+              </a:rPr>
+              <a:t>Original paper: MT-Bench judge-human agreement table (Table 5)</a:t>
+            </a:r>
+          </a:p>
+        </p:txBody>
+      </p:sp>
+      <p:sp>
+        <p:nvSpPr>
+          <p:cNvPr id="10" name="TextBox 9"/>
+          <p:cNvSpPr txBox="1"/>
+          <p:nvPr/>
+        </p:nvSpPr>
+        <p:spPr>
+          <a:xfrm>
+            <a:off x="4480560" y="4626864"/>
+            <a:ext cx="3474720" cy="219456"/>
+          </a:xfrm>
+          <a:prstGeom prst="rect">
+            <a:avLst/>
+          </a:prstGeom>
+          <a:noFill/>
+          <a:ln>
+            <a:noFill/>
+          </a:ln>
+        </p:spPr>
+        <p:txBody>
+          <a:bodyPr wrap="square" lIns="73152" rIns="73152" tIns="73152" bIns="73152" anchor="t">
+            <a:spAutoFit/>
+          </a:bodyPr>
+          <a:lstStyle/>
+          <a:p>
+            <a:pPr algn="ctr"/>
+            <a:r>
+              <a:rPr sz="1100" b="0">
+                <a:solidFill>
+                  <a:srgbClr val="6D7780"/>
+                </a:solidFill>
+                <a:latin typeface="Apple SD Gothic Neo"/>
+              </a:rPr>
+              <a:t>Original paper: MT-Bench score table for model variants (Table 8)</a:t>
+            </a:r>
+          </a:p>
+        </p:txBody>
+      </p:sp>
+      <p:sp>
+        <p:nvSpPr>
+          <p:cNvPr id="11" name="TextBox 10"/>
+          <p:cNvSpPr txBox="1"/>
+          <p:nvPr/>
+        </p:nvSpPr>
+        <p:spPr>
+          <a:xfrm>
+            <a:off x="8183879" y="1298448"/>
+            <a:ext cx="3246120" cy="4709160"/>
           </a:xfrm>
           <a:prstGeom prst="rect">
             <a:avLst/>
@@ -16203,7 +15841,7 @@
           </a:ln>
         </p:spPr>
         <p:txBody>
-          <a:bodyPr wrap="square" lIns="73152" rIns="73152" tIns="73152" bIns="73152" anchor="t">
+          <a:bodyPr wrap="square" lIns="128016" rIns="128016" tIns="128016" bIns="128016" anchor="t">
             <a:spAutoFit/>
           </a:bodyPr>
           <a:lstStyle/>
@@ -16218,7 +15856,7 @@
               <a:spcAft>
                 <a:spcPts val="900"/>
               </a:spcAft>
-              <a:defRPr sz="1800">
+              <a:defRPr sz="1700">
                 <a:solidFill>
                   <a:srgbClr val="36454F"/>
                 </a:solidFill>
@@ -16240,7 +15878,7 @@
               <a:spcAft>
                 <a:spcPts val="900"/>
               </a:spcAft>
-              <a:defRPr sz="1800">
+              <a:defRPr sz="1700">
                 <a:solidFill>
                   <a:srgbClr val="36454F"/>
                 </a:solidFill>
@@ -16262,7 +15900,7 @@
               <a:spcAft>
                 <a:spcPts val="900"/>
               </a:spcAft>
-              <a:defRPr sz="1800">
+              <a:defRPr sz="1700">
                 <a:solidFill>
                   <a:srgbClr val="36454F"/>
                 </a:solidFill>
@@ -16284,7 +15922,7 @@
               <a:spcAft>
                 <a:spcPts val="900"/>
               </a:spcAft>
-              <a:defRPr sz="1800">
+              <a:defRPr sz="1700">
                 <a:solidFill>
                   <a:srgbClr val="36454F"/>
                 </a:solidFill>
@@ -16299,104 +15937,20 @@
       </p:sp>
       <p:sp>
         <p:nvSpPr>
-          <p:cNvPr id="7" name="TextBox 6"/>
-          <p:cNvSpPr txBox="1"/>
-          <p:nvPr/>
-        </p:nvSpPr>
-        <p:spPr>
-          <a:xfrm>
-            <a:off x="6446520" y="1298448"/>
-            <a:ext cx="4709160" cy="658368"/>
+          <p:cNvPr id="12" name="Rectangle 11"/>
+          <p:cNvSpPr/>
+          <p:nvPr/>
+        </p:nvSpPr>
+        <p:spPr>
+          <a:xfrm>
+            <a:off x="384048" y="6510528"/>
+            <a:ext cx="11384280" cy="36576"/>
           </a:xfrm>
           <a:prstGeom prst="rect">
             <a:avLst/>
           </a:prstGeom>
           <a:solidFill>
-            <a:srgbClr val="13283A"/>
-          </a:solidFill>
-          <a:ln>
-            <a:solidFill>
-              <a:srgbClr val="13283A"/>
-            </a:solidFill>
-          </a:ln>
-        </p:spPr>
-        <p:txBody>
-          <a:bodyPr wrap="square" lIns="73152" rIns="73152" tIns="73152" bIns="73152" anchor="ctr">
-            <a:spAutoFit/>
-          </a:bodyPr>
-          <a:lstStyle/>
-          <a:p>
-            <a:pPr algn="l"/>
-            <a:r>
-              <a:rPr sz="1900" b="1">
-                <a:solidFill>
-                  <a:srgbClr val="FFFFFF"/>
-                </a:solidFill>
-                <a:latin typeface="Apple SD Gothic Neo"/>
-              </a:rPr>
-              <a:t>원 논문의 결론은 ‘GPT-4 judge가 완벽하다’가 아니라, ‘인간 선호를 실용적으로 근사할 수 있다’였습니다.</a:t>
-            </a:r>
-          </a:p>
-        </p:txBody>
-      </p:sp>
-      <p:sp>
-        <p:nvSpPr>
-          <p:cNvPr id="8" name="TextBox 7"/>
-          <p:cNvSpPr txBox="1"/>
-          <p:nvPr/>
-        </p:nvSpPr>
-        <p:spPr>
-          <a:xfrm>
-            <a:off x="6510528" y="2377440"/>
-            <a:ext cx="1645920" cy="868680"/>
-          </a:xfrm>
-          <a:prstGeom prst="rect">
-            <a:avLst/>
-          </a:prstGeom>
-          <a:solidFill>
-            <a:srgbClr val="FFFFFF"/>
-          </a:solidFill>
-          <a:ln>
-            <a:solidFill>
-              <a:srgbClr val="E9E5DB"/>
-            </a:solidFill>
-          </a:ln>
-        </p:spPr>
-        <p:txBody>
-          <a:bodyPr wrap="square" lIns="109728" rIns="109728" tIns="109728" bIns="109728" anchor="t">
-            <a:spAutoFit/>
-          </a:bodyPr>
-          <a:lstStyle/>
-          <a:p>
-            <a:pPr algn="l"/>
-            <a:r>
-              <a:rPr sz="1800" b="0">
-                <a:solidFill>
-                  <a:srgbClr val="36454F"/>
-                </a:solidFill>
-                <a:latin typeface="Apple SD Gothic Neo"/>
-              </a:rPr>
-              <a:t/>
-            </a:r>
-          </a:p>
-        </p:txBody>
-      </p:sp>
-      <p:sp>
-        <p:nvSpPr>
-          <p:cNvPr id="9" name="Rounded Rectangle 8"/>
-          <p:cNvSpPr/>
-          <p:nvPr/>
-        </p:nvSpPr>
-        <p:spPr>
-          <a:xfrm>
-            <a:off x="6620256" y="2487168"/>
-            <a:ext cx="438912" cy="201168"/>
-          </a:xfrm>
-          <a:prstGeom prst="roundRect">
-            <a:avLst/>
-          </a:prstGeom>
-          <a:solidFill>
-            <a:srgbClr val="B45C45"/>
+            <a:srgbClr val="E9E5DB"/>
           </a:solidFill>
           <a:ln>
             <a:noFill/>
@@ -16426,609 +15980,7 @@
       </p:sp>
       <p:sp>
         <p:nvSpPr>
-          <p:cNvPr id="10" name="TextBox 9"/>
-          <p:cNvSpPr txBox="1"/>
-          <p:nvPr/>
-        </p:nvSpPr>
-        <p:spPr>
-          <a:xfrm>
-            <a:off x="6620256" y="2542032"/>
-            <a:ext cx="1417320" cy="164592"/>
-          </a:xfrm>
-          <a:prstGeom prst="rect">
-            <a:avLst/>
-          </a:prstGeom>
-          <a:noFill/>
-          <a:ln>
-            <a:noFill/>
-          </a:ln>
-        </p:spPr>
-        <p:txBody>
-          <a:bodyPr wrap="square" lIns="18288" rIns="18288" tIns="18288" bIns="18288" anchor="ctr">
-            <a:spAutoFit/>
-          </a:bodyPr>
-          <a:lstStyle/>
-          <a:p>
-            <a:pPr algn="l"/>
-            <a:r>
-              <a:rPr sz="1000" b="1">
-                <a:solidFill>
-                  <a:srgbClr val="FFFFFF"/>
-                </a:solidFill>
-                <a:latin typeface="Apple SD Gothic Neo"/>
-              </a:rPr>
-              <a:t>MT-Bench</a:t>
-            </a:r>
-          </a:p>
-        </p:txBody>
-      </p:sp>
-      <p:sp>
-        <p:nvSpPr>
-          <p:cNvPr id="11" name="TextBox 10"/>
-          <p:cNvSpPr txBox="1"/>
-          <p:nvPr/>
-        </p:nvSpPr>
-        <p:spPr>
-          <a:xfrm>
-            <a:off x="6620256" y="2761488"/>
-            <a:ext cx="1426464" cy="320040"/>
-          </a:xfrm>
-          <a:prstGeom prst="rect">
-            <a:avLst/>
-          </a:prstGeom>
-          <a:noFill/>
-          <a:ln>
-            <a:noFill/>
-          </a:ln>
-        </p:spPr>
-        <p:txBody>
-          <a:bodyPr wrap="square" lIns="18288" rIns="18288" tIns="18288" bIns="18288" anchor="t">
-            <a:spAutoFit/>
-          </a:bodyPr>
-          <a:lstStyle/>
-          <a:p>
-            <a:pPr algn="l"/>
-            <a:r>
-              <a:rPr sz="2100" b="1">
-                <a:solidFill>
-                  <a:srgbClr val="13283A"/>
-                </a:solidFill>
-                <a:latin typeface="Apple SD Gothic Neo"/>
-              </a:rPr>
-              <a:t>85%</a:t>
-            </a:r>
-          </a:p>
-        </p:txBody>
-      </p:sp>
-      <p:sp>
-        <p:nvSpPr>
-          <p:cNvPr id="12" name="TextBox 11"/>
-          <p:cNvSpPr txBox="1"/>
-          <p:nvPr/>
-        </p:nvSpPr>
-        <p:spPr>
-          <a:xfrm>
-            <a:off x="8979408" y="2377440"/>
-            <a:ext cx="1645920" cy="868680"/>
-          </a:xfrm>
-          <a:prstGeom prst="rect">
-            <a:avLst/>
-          </a:prstGeom>
-          <a:solidFill>
-            <a:srgbClr val="FFFFFF"/>
-          </a:solidFill>
-          <a:ln>
-            <a:solidFill>
-              <a:srgbClr val="E9E5DB"/>
-            </a:solidFill>
-          </a:ln>
-        </p:spPr>
-        <p:txBody>
-          <a:bodyPr wrap="square" lIns="109728" rIns="109728" tIns="109728" bIns="109728" anchor="t">
-            <a:spAutoFit/>
-          </a:bodyPr>
-          <a:lstStyle/>
-          <a:p>
-            <a:pPr algn="l"/>
-            <a:r>
-              <a:rPr sz="1800" b="0">
-                <a:solidFill>
-                  <a:srgbClr val="36454F"/>
-                </a:solidFill>
-                <a:latin typeface="Apple SD Gothic Neo"/>
-              </a:rPr>
-              <a:t/>
-            </a:r>
-          </a:p>
-        </p:txBody>
-      </p:sp>
-      <p:sp>
-        <p:nvSpPr>
-          <p:cNvPr id="13" name="Rounded Rectangle 12"/>
-          <p:cNvSpPr/>
-          <p:nvPr/>
-        </p:nvSpPr>
-        <p:spPr>
-          <a:xfrm>
-            <a:off x="9089136" y="2487168"/>
-            <a:ext cx="438912" cy="201168"/>
-          </a:xfrm>
-          <a:prstGeom prst="roundRect">
-            <a:avLst/>
-          </a:prstGeom>
-          <a:solidFill>
-            <a:srgbClr val="607A60"/>
-          </a:solidFill>
-          <a:ln>
-            <a:noFill/>
-          </a:ln>
-        </p:spPr>
-        <p:style>
-          <a:lnRef idx="1">
-            <a:schemeClr val="accent1"/>
-          </a:lnRef>
-          <a:fillRef idx="3">
-            <a:schemeClr val="accent1"/>
-          </a:fillRef>
-          <a:effectRef idx="2">
-            <a:schemeClr val="accent1"/>
-          </a:effectRef>
-          <a:fontRef idx="minor">
-            <a:schemeClr val="lt1"/>
-          </a:fontRef>
-        </p:style>
-        <p:txBody>
-          <a:bodyPr rtlCol="0" anchor="ctr"/>
-          <a:lstStyle/>
-          <a:p>
-            <a:pPr algn="ctr"/>
-          </a:p>
-        </p:txBody>
-      </p:sp>
-      <p:sp>
-        <p:nvSpPr>
-          <p:cNvPr id="14" name="TextBox 13"/>
-          <p:cNvSpPr txBox="1"/>
-          <p:nvPr/>
-        </p:nvSpPr>
-        <p:spPr>
-          <a:xfrm>
-            <a:off x="9089136" y="2542032"/>
-            <a:ext cx="1417320" cy="164592"/>
-          </a:xfrm>
-          <a:prstGeom prst="rect">
-            <a:avLst/>
-          </a:prstGeom>
-          <a:noFill/>
-          <a:ln>
-            <a:noFill/>
-          </a:ln>
-        </p:spPr>
-        <p:txBody>
-          <a:bodyPr wrap="square" lIns="18288" rIns="18288" tIns="18288" bIns="18288" anchor="ctr">
-            <a:spAutoFit/>
-          </a:bodyPr>
-          <a:lstStyle/>
-          <a:p>
-            <a:pPr algn="l"/>
-            <a:r>
-              <a:rPr sz="1000" b="1">
-                <a:solidFill>
-                  <a:srgbClr val="FFFFFF"/>
-                </a:solidFill>
-                <a:latin typeface="Apple SD Gothic Neo"/>
-              </a:rPr>
-              <a:t>Human↔Human</a:t>
-            </a:r>
-          </a:p>
-        </p:txBody>
-      </p:sp>
-      <p:sp>
-        <p:nvSpPr>
-          <p:cNvPr id="15" name="TextBox 14"/>
-          <p:cNvSpPr txBox="1"/>
-          <p:nvPr/>
-        </p:nvSpPr>
-        <p:spPr>
-          <a:xfrm>
-            <a:off x="9089136" y="2761488"/>
-            <a:ext cx="1426464" cy="320040"/>
-          </a:xfrm>
-          <a:prstGeom prst="rect">
-            <a:avLst/>
-          </a:prstGeom>
-          <a:noFill/>
-          <a:ln>
-            <a:noFill/>
-          </a:ln>
-        </p:spPr>
-        <p:txBody>
-          <a:bodyPr wrap="square" lIns="18288" rIns="18288" tIns="18288" bIns="18288" anchor="t">
-            <a:spAutoFit/>
-          </a:bodyPr>
-          <a:lstStyle/>
-          <a:p>
-            <a:pPr algn="l"/>
-            <a:r>
-              <a:rPr sz="2100" b="1">
-                <a:solidFill>
-                  <a:srgbClr val="13283A"/>
-                </a:solidFill>
-                <a:latin typeface="Apple SD Gothic Neo"/>
-              </a:rPr>
-              <a:t>81%</a:t>
-            </a:r>
-          </a:p>
-        </p:txBody>
-      </p:sp>
-      <p:sp>
-        <p:nvSpPr>
-          <p:cNvPr id="16" name="TextBox 15"/>
-          <p:cNvSpPr txBox="1"/>
-          <p:nvPr/>
-        </p:nvSpPr>
-        <p:spPr>
-          <a:xfrm>
-            <a:off x="6510528" y="3547872"/>
-            <a:ext cx="1645920" cy="868680"/>
-          </a:xfrm>
-          <a:prstGeom prst="rect">
-            <a:avLst/>
-          </a:prstGeom>
-          <a:solidFill>
-            <a:srgbClr val="FFFFFF"/>
-          </a:solidFill>
-          <a:ln>
-            <a:solidFill>
-              <a:srgbClr val="E9E5DB"/>
-            </a:solidFill>
-          </a:ln>
-        </p:spPr>
-        <p:txBody>
-          <a:bodyPr wrap="square" lIns="109728" rIns="109728" tIns="109728" bIns="109728" anchor="t">
-            <a:spAutoFit/>
-          </a:bodyPr>
-          <a:lstStyle/>
-          <a:p>
-            <a:pPr algn="l"/>
-            <a:r>
-              <a:rPr sz="1800" b="0">
-                <a:solidFill>
-                  <a:srgbClr val="36454F"/>
-                </a:solidFill>
-                <a:latin typeface="Apple SD Gothic Neo"/>
-              </a:rPr>
-              <a:t/>
-            </a:r>
-          </a:p>
-        </p:txBody>
-      </p:sp>
-      <p:sp>
-        <p:nvSpPr>
-          <p:cNvPr id="17" name="Rounded Rectangle 16"/>
-          <p:cNvSpPr/>
-          <p:nvPr/>
-        </p:nvSpPr>
-        <p:spPr>
-          <a:xfrm>
-            <a:off x="6620256" y="3657600"/>
-            <a:ext cx="438912" cy="201168"/>
-          </a:xfrm>
-          <a:prstGeom prst="roundRect">
-            <a:avLst/>
-          </a:prstGeom>
-          <a:solidFill>
-            <a:srgbClr val="C0944A"/>
-          </a:solidFill>
-          <a:ln>
-            <a:noFill/>
-          </a:ln>
-        </p:spPr>
-        <p:style>
-          <a:lnRef idx="1">
-            <a:schemeClr val="accent1"/>
-          </a:lnRef>
-          <a:fillRef idx="3">
-            <a:schemeClr val="accent1"/>
-          </a:fillRef>
-          <a:effectRef idx="2">
-            <a:schemeClr val="accent1"/>
-          </a:effectRef>
-          <a:fontRef idx="minor">
-            <a:schemeClr val="lt1"/>
-          </a:fontRef>
-        </p:style>
-        <p:txBody>
-          <a:bodyPr rtlCol="0" anchor="ctr"/>
-          <a:lstStyle/>
-          <a:p>
-            <a:pPr algn="ctr"/>
-          </a:p>
-        </p:txBody>
-      </p:sp>
-      <p:sp>
-        <p:nvSpPr>
-          <p:cNvPr id="18" name="TextBox 17"/>
-          <p:cNvSpPr txBox="1"/>
-          <p:nvPr/>
-        </p:nvSpPr>
-        <p:spPr>
-          <a:xfrm>
-            <a:off x="6620256" y="3712464"/>
-            <a:ext cx="1417320" cy="164592"/>
-          </a:xfrm>
-          <a:prstGeom prst="rect">
-            <a:avLst/>
-          </a:prstGeom>
-          <a:noFill/>
-          <a:ln>
-            <a:noFill/>
-          </a:ln>
-        </p:spPr>
-        <p:txBody>
-          <a:bodyPr wrap="square" lIns="18288" rIns="18288" tIns="18288" bIns="18288" anchor="ctr">
-            <a:spAutoFit/>
-          </a:bodyPr>
-          <a:lstStyle/>
-          <a:p>
-            <a:pPr algn="l"/>
-            <a:r>
-              <a:rPr sz="1000" b="1">
-                <a:solidFill>
-                  <a:srgbClr val="FFFFFF"/>
-                </a:solidFill>
-                <a:latin typeface="Apple SD Gothic Neo"/>
-              </a:rPr>
-              <a:t>Arena</a:t>
-            </a:r>
-          </a:p>
-        </p:txBody>
-      </p:sp>
-      <p:sp>
-        <p:nvSpPr>
-          <p:cNvPr id="19" name="TextBox 18"/>
-          <p:cNvSpPr txBox="1"/>
-          <p:nvPr/>
-        </p:nvSpPr>
-        <p:spPr>
-          <a:xfrm>
-            <a:off x="6620256" y="3931920"/>
-            <a:ext cx="1426464" cy="320040"/>
-          </a:xfrm>
-          <a:prstGeom prst="rect">
-            <a:avLst/>
-          </a:prstGeom>
-          <a:noFill/>
-          <a:ln>
-            <a:noFill/>
-          </a:ln>
-        </p:spPr>
-        <p:txBody>
-          <a:bodyPr wrap="square" lIns="18288" rIns="18288" tIns="18288" bIns="18288" anchor="t">
-            <a:spAutoFit/>
-          </a:bodyPr>
-          <a:lstStyle/>
-          <a:p>
-            <a:pPr algn="l"/>
-            <a:r>
-              <a:rPr sz="2100" b="1">
-                <a:solidFill>
-                  <a:srgbClr val="13283A"/>
-                </a:solidFill>
-                <a:latin typeface="Apple SD Gothic Neo"/>
-              </a:rPr>
-              <a:t>87%</a:t>
-            </a:r>
-          </a:p>
-        </p:txBody>
-      </p:sp>
-      <p:sp>
-        <p:nvSpPr>
-          <p:cNvPr id="20" name="TextBox 19"/>
-          <p:cNvSpPr txBox="1"/>
-          <p:nvPr/>
-        </p:nvSpPr>
-        <p:spPr>
-          <a:xfrm>
-            <a:off x="8979408" y="3547872"/>
-            <a:ext cx="1645920" cy="868680"/>
-          </a:xfrm>
-          <a:prstGeom prst="rect">
-            <a:avLst/>
-          </a:prstGeom>
-          <a:solidFill>
-            <a:srgbClr val="FFFFFF"/>
-          </a:solidFill>
-          <a:ln>
-            <a:solidFill>
-              <a:srgbClr val="E9E5DB"/>
-            </a:solidFill>
-          </a:ln>
-        </p:spPr>
-        <p:txBody>
-          <a:bodyPr wrap="square" lIns="109728" rIns="109728" tIns="109728" bIns="109728" anchor="t">
-            <a:spAutoFit/>
-          </a:bodyPr>
-          <a:lstStyle/>
-          <a:p>
-            <a:pPr algn="l"/>
-            <a:r>
-              <a:rPr sz="1800" b="0">
-                <a:solidFill>
-                  <a:srgbClr val="36454F"/>
-                </a:solidFill>
-                <a:latin typeface="Apple SD Gothic Neo"/>
-              </a:rPr>
-              <a:t/>
-            </a:r>
-          </a:p>
-        </p:txBody>
-      </p:sp>
-      <p:sp>
-        <p:nvSpPr>
-          <p:cNvPr id="21" name="Rounded Rectangle 20"/>
-          <p:cNvSpPr/>
-          <p:nvPr/>
-        </p:nvSpPr>
-        <p:spPr>
-          <a:xfrm>
-            <a:off x="9089136" y="3657600"/>
-            <a:ext cx="438912" cy="201168"/>
-          </a:xfrm>
-          <a:prstGeom prst="roundRect">
-            <a:avLst/>
-          </a:prstGeom>
-          <a:solidFill>
-            <a:srgbClr val="13283A"/>
-          </a:solidFill>
-          <a:ln>
-            <a:noFill/>
-          </a:ln>
-        </p:spPr>
-        <p:style>
-          <a:lnRef idx="1">
-            <a:schemeClr val="accent1"/>
-          </a:lnRef>
-          <a:fillRef idx="3">
-            <a:schemeClr val="accent1"/>
-          </a:fillRef>
-          <a:effectRef idx="2">
-            <a:schemeClr val="accent1"/>
-          </a:effectRef>
-          <a:fontRef idx="minor">
-            <a:schemeClr val="lt1"/>
-          </a:fontRef>
-        </p:style>
-        <p:txBody>
-          <a:bodyPr rtlCol="0" anchor="ctr"/>
-          <a:lstStyle/>
-          <a:p>
-            <a:pPr algn="ctr"/>
-          </a:p>
-        </p:txBody>
-      </p:sp>
-      <p:sp>
-        <p:nvSpPr>
-          <p:cNvPr id="22" name="TextBox 21"/>
-          <p:cNvSpPr txBox="1"/>
-          <p:nvPr/>
-        </p:nvSpPr>
-        <p:spPr>
-          <a:xfrm>
-            <a:off x="9089136" y="3712464"/>
-            <a:ext cx="1417320" cy="164592"/>
-          </a:xfrm>
-          <a:prstGeom prst="rect">
-            <a:avLst/>
-          </a:prstGeom>
-          <a:noFill/>
-          <a:ln>
-            <a:noFill/>
-          </a:ln>
-        </p:spPr>
-        <p:txBody>
-          <a:bodyPr wrap="square" lIns="18288" rIns="18288" tIns="18288" bIns="18288" anchor="ctr">
-            <a:spAutoFit/>
-          </a:bodyPr>
-          <a:lstStyle/>
-          <a:p>
-            <a:pPr algn="l"/>
-            <a:r>
-              <a:rPr sz="1000" b="1">
-                <a:solidFill>
-                  <a:srgbClr val="FFFFFF"/>
-                </a:solidFill>
-                <a:latin typeface="Apple SD Gothic Neo"/>
-              </a:rPr>
-              <a:t>GPT-4 score</a:t>
-            </a:r>
-          </a:p>
-        </p:txBody>
-      </p:sp>
-      <p:sp>
-        <p:nvSpPr>
-          <p:cNvPr id="23" name="TextBox 22"/>
-          <p:cNvSpPr txBox="1"/>
-          <p:nvPr/>
-        </p:nvSpPr>
-        <p:spPr>
-          <a:xfrm>
-            <a:off x="9089136" y="3931920"/>
-            <a:ext cx="1426464" cy="320040"/>
-          </a:xfrm>
-          <a:prstGeom prst="rect">
-            <a:avLst/>
-          </a:prstGeom>
-          <a:noFill/>
-          <a:ln>
-            <a:noFill/>
-          </a:ln>
-        </p:spPr>
-        <p:txBody>
-          <a:bodyPr wrap="square" lIns="18288" rIns="18288" tIns="18288" bIns="18288" anchor="t">
-            <a:spAutoFit/>
-          </a:bodyPr>
-          <a:lstStyle/>
-          <a:p>
-            <a:pPr algn="l"/>
-            <a:r>
-              <a:rPr sz="2100" b="1">
-                <a:solidFill>
-                  <a:srgbClr val="13283A"/>
-                </a:solidFill>
-                <a:latin typeface="Apple SD Gothic Neo"/>
-              </a:rPr>
-              <a:t>8.99</a:t>
-            </a:r>
-          </a:p>
-        </p:txBody>
-      </p:sp>
-      <p:sp>
-        <p:nvSpPr>
-          <p:cNvPr id="24" name="Rectangle 23"/>
-          <p:cNvSpPr/>
-          <p:nvPr/>
-        </p:nvSpPr>
-        <p:spPr>
-          <a:xfrm>
-            <a:off x="384048" y="6510528"/>
-            <a:ext cx="11384280" cy="36576"/>
-          </a:xfrm>
-          <a:prstGeom prst="rect">
-            <a:avLst/>
-          </a:prstGeom>
-          <a:solidFill>
-            <a:srgbClr val="E9E5DB"/>
-          </a:solidFill>
-          <a:ln>
-            <a:noFill/>
-          </a:ln>
-        </p:spPr>
-        <p:style>
-          <a:lnRef idx="1">
-            <a:schemeClr val="accent1"/>
-          </a:lnRef>
-          <a:fillRef idx="3">
-            <a:schemeClr val="accent1"/>
-          </a:fillRef>
-          <a:effectRef idx="2">
-            <a:schemeClr val="accent1"/>
-          </a:effectRef>
-          <a:fontRef idx="minor">
-            <a:schemeClr val="lt1"/>
-          </a:fontRef>
-        </p:style>
-        <p:txBody>
-          <a:bodyPr rtlCol="0" anchor="ctr"/>
-          <a:lstStyle/>
-          <a:p>
-            <a:pPr algn="ctr"/>
-          </a:p>
-        </p:txBody>
-      </p:sp>
-      <p:sp>
-        <p:nvSpPr>
-          <p:cNvPr id="25" name="TextBox 24"/>
+          <p:cNvPr id="13" name="TextBox 12"/>
           <p:cNvSpPr txBox="1"/>
           <p:nvPr/>
         </p:nvSpPr>

</xml_diff>